<commit_message>
VLMSync up 3 updated with new graph
</commit_message>
<xml_diff>
--- a/week-04/VLMSync3.pptx
+++ b/week-04/VLMSync3.pptx
@@ -5,7 +5,7 @@
     <p:sldMasterId id="2147483648" r:id="rId1"/>
   </p:sldMasterIdLst>
   <p:notesMasterIdLst>
-    <p:notesMasterId r:id="rId16"/>
+    <p:notesMasterId r:id="rId17"/>
   </p:notesMasterIdLst>
   <p:sldIdLst>
     <p:sldId id="256" r:id="rId2"/>
@@ -17,11 +17,12 @@
     <p:sldId id="261" r:id="rId8"/>
     <p:sldId id="264" r:id="rId9"/>
     <p:sldId id="263" r:id="rId10"/>
-    <p:sldId id="265" r:id="rId11"/>
-    <p:sldId id="267" r:id="rId12"/>
-    <p:sldId id="269" r:id="rId13"/>
-    <p:sldId id="268" r:id="rId14"/>
-    <p:sldId id="270" r:id="rId15"/>
+    <p:sldId id="271" r:id="rId11"/>
+    <p:sldId id="265" r:id="rId12"/>
+    <p:sldId id="267" r:id="rId13"/>
+    <p:sldId id="269" r:id="rId14"/>
+    <p:sldId id="268" r:id="rId15"/>
+    <p:sldId id="270" r:id="rId16"/>
   </p:sldIdLst>
   <p:sldSz cx="16256000" cy="9144000"/>
   <p:notesSz cx="9144000" cy="16256000"/>
@@ -3730,7 +3731,7 @@
           <a:p>
             <a:fld id="{F7021451-1387-4CA6-816F-3879F97B5CBC}" type="slidenum">
               <a:rPr lang="en-US"/>
-              <a:t>10</a:t>
+              <a:t>11</a:t>
             </a:fld>
             <a:endParaRPr lang="en-US"/>
           </a:p>
@@ -5105,6 +5106,113 @@
 
 <file path=ppt/slides/slide10.xml><?xml version="1.0" encoding="utf-8"?>
 <p:sld xmlns:a="http://schemas.openxmlformats.org/drawingml/2006/main" xmlns:r="http://schemas.openxmlformats.org/officeDocument/2006/relationships" xmlns:p="http://schemas.openxmlformats.org/presentationml/2006/main">
+  <p:cSld>
+    <p:spTree>
+      <p:nvGrpSpPr>
+        <p:cNvPr id="1" name=""/>
+        <p:cNvGrpSpPr/>
+        <p:nvPr/>
+      </p:nvGrpSpPr>
+      <p:grpSpPr>
+        <a:xfrm>
+          <a:off x="0" y="0"/>
+          <a:ext cx="0" cy="0"/>
+          <a:chOff x="0" y="0"/>
+          <a:chExt cx="0" cy="0"/>
+        </a:xfrm>
+      </p:grpSpPr>
+      <p:sp>
+        <p:nvSpPr>
+          <p:cNvPr id="2" name="Text 0">
+            <a:extLst>
+              <a:ext uri="{FF2B5EF4-FFF2-40B4-BE49-F238E27FC236}">
+                <a16:creationId xmlns:a16="http://schemas.microsoft.com/office/drawing/2014/main" id="{2E2C2207-F525-3383-9D65-841E22287A4C}"/>
+              </a:ext>
+            </a:extLst>
+          </p:cNvPr>
+          <p:cNvSpPr/>
+          <p:nvPr/>
+        </p:nvSpPr>
+        <p:spPr>
+          <a:xfrm>
+            <a:off x="1016000" y="508000"/>
+            <a:ext cx="11430000" cy="609600"/>
+          </a:xfrm>
+          <a:prstGeom prst="rect">
+            <a:avLst/>
+          </a:prstGeom>
+          <a:noFill/>
+          <a:ln/>
+        </p:spPr>
+        <p:txBody>
+          <a:bodyPr wrap="square" lIns="0" tIns="0" rIns="0" bIns="0" rtlCol="0" anchor="ctr"/>
+          <a:lstStyle/>
+          <a:p>
+            <a:pPr algn="l">
+              <a:lnSpc>
+                <a:spcPct val="130000"/>
+              </a:lnSpc>
+            </a:pPr>
+            <a:r>
+              <a:rPr lang="en-US" sz="3600" b="1" dirty="0">
+                <a:solidFill>
+                  <a:srgbClr val="333C40"/>
+                </a:solidFill>
+                <a:latin typeface="Liter" pitchFamily="34" charset="0"/>
+                <a:ea typeface="Liter" pitchFamily="34" charset="-122"/>
+                <a:cs typeface="Liter" pitchFamily="34" charset="-120"/>
+              </a:rPr>
+              <a:t>Policy Coverage Updated by Qwen-397b</a:t>
+            </a:r>
+            <a:endParaRPr lang="en-US" sz="3600" dirty="0"/>
+          </a:p>
+        </p:txBody>
+      </p:sp>
+      <p:pic>
+        <p:nvPicPr>
+          <p:cNvPr id="3" name="Picture 2" descr="Screenshot 2026-06-18 at 9.10.23 AM 2.png">
+            <a:extLst>
+              <a:ext uri="{FF2B5EF4-FFF2-40B4-BE49-F238E27FC236}">
+                <a16:creationId xmlns:a16="http://schemas.microsoft.com/office/drawing/2014/main" id="{673F7E65-9C69-D9BF-B1F4-550EDB89A23B}"/>
+              </a:ext>
+            </a:extLst>
+          </p:cNvPr>
+          <p:cNvPicPr>
+            <a:picLocks noChangeAspect="1"/>
+          </p:cNvPicPr>
+          <p:nvPr/>
+        </p:nvPicPr>
+        <p:blipFill>
+          <a:blip r:embed="rId2"/>
+          <a:stretch>
+            <a:fillRect/>
+          </a:stretch>
+        </p:blipFill>
+        <p:spPr>
+          <a:xfrm>
+            <a:off x="1171621" y="1787237"/>
+            <a:ext cx="13687933" cy="6320286"/>
+          </a:xfrm>
+          <a:prstGeom prst="rect">
+            <a:avLst/>
+          </a:prstGeom>
+        </p:spPr>
+      </p:pic>
+    </p:spTree>
+    <p:extLst>
+      <p:ext uri="{BB962C8B-B14F-4D97-AF65-F5344CB8AC3E}">
+        <p14:creationId xmlns:p14="http://schemas.microsoft.com/office/powerpoint/2010/main" val="3061343168"/>
+      </p:ext>
+    </p:extLst>
+  </p:cSld>
+  <p:clrMapOvr>
+    <a:masterClrMapping/>
+  </p:clrMapOvr>
+</p:sld>
+</file>
+
+<file path=ppt/slides/slide11.xml><?xml version="1.0" encoding="utf-8"?>
+<p:sld xmlns:a="http://schemas.openxmlformats.org/drawingml/2006/main" xmlns:r="http://schemas.openxmlformats.org/officeDocument/2006/relationships" xmlns:p="http://schemas.openxmlformats.org/presentationml/2006/main">
   <p:cSld name="Slide 10">
     <p:bg>
       <p:bgPr>
@@ -5479,7 +5587,7 @@
 </p:sld>
 </file>
 
-<file path=ppt/slides/slide11.xml><?xml version="1.0" encoding="utf-8"?>
+<file path=ppt/slides/slide12.xml><?xml version="1.0" encoding="utf-8"?>
 <p:sld xmlns:a="http://schemas.openxmlformats.org/drawingml/2006/main" xmlns:r="http://schemas.openxmlformats.org/officeDocument/2006/relationships" xmlns:p="http://schemas.openxmlformats.org/presentationml/2006/main">
   <p:cSld>
     <p:spTree>
@@ -5583,7 +5691,7 @@
 </p:sld>
 </file>
 
-<file path=ppt/slides/slide12.xml><?xml version="1.0" encoding="utf-8"?>
+<file path=ppt/slides/slide13.xml><?xml version="1.0" encoding="utf-8"?>
 <p:sld xmlns:a="http://schemas.openxmlformats.org/drawingml/2006/main" xmlns:r="http://schemas.openxmlformats.org/officeDocument/2006/relationships" xmlns:p="http://schemas.openxmlformats.org/presentationml/2006/main">
   <p:cSld>
     <p:spTree>
@@ -5687,7 +5795,7 @@
 </p:sld>
 </file>
 
-<file path=ppt/slides/slide13.xml><?xml version="1.0" encoding="utf-8"?>
+<file path=ppt/slides/slide14.xml><?xml version="1.0" encoding="utf-8"?>
 <p:sld xmlns:a="http://schemas.openxmlformats.org/drawingml/2006/main" xmlns:r="http://schemas.openxmlformats.org/officeDocument/2006/relationships" xmlns:p="http://schemas.openxmlformats.org/presentationml/2006/main">
   <p:cSld>
     <p:spTree>
@@ -5791,7 +5899,7 @@
 </p:sld>
 </file>
 
-<file path=ppt/slides/slide14.xml><?xml version="1.0" encoding="utf-8"?>
+<file path=ppt/slides/slide15.xml><?xml version="1.0" encoding="utf-8"?>
 <p:sld xmlns:a="http://schemas.openxmlformats.org/drawingml/2006/main" xmlns:r="http://schemas.openxmlformats.org/officeDocument/2006/relationships" xmlns:p="http://schemas.openxmlformats.org/presentationml/2006/main">
   <p:cSld>
     <p:spTree>

</xml_diff>